<commit_message>
Fix flow problems found in a full course read-through
Ergoluma and case 10 Rangka Waja now measure delivery from the
purchase order, so their only problems are the planned ones. The 6.4
deck prompt carries the facts, the memo box sits under 6.3, the
Module 01 gap reads RM1,080.00, 3.5 no longer asks the Checker to
choose, and 7.4 warns before the example rules. Module 11 adds the
defence as the first rule, with an n8n version. The Copilot card,
Module 13 notes, deck notes and program flow now match the modules,
and the home page lists Excel. Deck, banner and book rebuilt.

Co-Authored-By: Claude Opus 5.5 <noreply@anthropic.com>
Claude-Session: https://claude.ai/code/session_01F3jTzTeVDh4aZxEw8vbSHh
</commit_message>
<xml_diff>
--- a/AI-for-Workplace-Advanced-Deck.pptx
+++ b/AI-for-Workplace-Advanced-Deck.pptx
@@ -2021,7 +2021,7 @@
           <a:p>
             <a:r>
               <a:rPr lang="en-US" dirty="0"/>
-              <a:t>Tools that run code (ChatGPT, Claude, Gemini, Copilot's Analyst) are far more reliable for sums than tools that read the file as text.
+              <a:t>Tools that run code (ChatGPT, Claude, Gemini, and Copilot, which runs Python even on Basic) are far more reliable for sums than tools that read the file as text.
 The Excel PivotTable check in 5.3 shows why cleaning matters: one supplier's total comes out higher in Excel. Let them find out why.</a:t>
             </a:r>
             <a:endParaRPr lang="en-US" dirty="0"/>
@@ -2377,7 +2377,7 @@
             <a:r>
               <a:rPr lang="en-US" dirty="0"/>
               <a:t>About 50 minutes. Sample files: Module 06 ZIP. Needs desktop Word and PowerPoint.
-Copilot Chat (Basic) has no Copilot in the Office apps: those participants draft in chat and paste with Keep Text Only.</a:t>
+Copilot Chat (Basic) has no Copilot in the Office apps, but in chat it returns the filled .docx and .pptx to OneDrive. Paste with Keep Text Only only if a tool can't return a file.</a:t>
             </a:r>
             <a:endParaRPr lang="en-US" dirty="0"/>
           </a:p>
@@ -3884,7 +3884,7 @@
           <a:p>
             <a:r>
               <a:rPr lang="en-US" dirty="0"/>
-              <a:t>The longest lab. Check before class that the starter imports into your trial account and that everyone has a working AI credential.</a:t>
+              <a:t>The longest lab. Check before class that the starter imports into your trial account and that the trial shows Gateway credits (or the class credential works).</a:t>
             </a:r>
             <a:endParaRPr lang="en-US" dirty="0"/>
           </a:p>
@@ -31943,7 +31943,7 @@
                   <a:schemeClr val="tx1"/>
                 </a:solidFill>
               </a:rPr>
-              <a:t>After your fix, the poisoned quotation gets the right verdict and the hidden instruction is reported, and the original case still passes its re-test.</a:t>
+              <a:t>After your fix, the poisoned quotation gets the right verdict and the hidden instruction is reported, and case 09 still gets REVISE for the load alone, with no instruction finding.</a:t>
             </a:r>
             <a:endParaRPr lang="en-US" sz="1600" dirty="0"/>
           </a:p>

</xml_diff>

<commit_message>
Add a glossary, a locked-down path, a Module 10 demo option and HR Brief D
From the student run-through: a glossary page and an "If your company
blocks a tool" page in the product cards, linked from every module, the
home page, the sidebar and the book; a demo option for Module 10; and a
fourth capstone brief for HR teams (staff leave queries) with its data,
prompt, answer box and answer key. Deck and book rebuilt.

Co-Authored-By: Claude Opus 5.5 <noreply@anthropic.com>
Claude-Session: https://claude.ai/code/session_01F3jTzTeVDh4aZxEw8vbSHh
</commit_message>
<xml_diff>
--- a/AI-for-Workplace-Advanced-Deck.pptx
+++ b/AI-for-Workplace-Advanced-Deck.pptx
@@ -3884,7 +3884,8 @@
           <a:p>
             <a:r>
               <a:rPr lang="en-US" dirty="0"/>
-              <a:t>The longest lab. Check before class that the starter imports into your trial account and that the trial shows Gateway credits (or the class credential works).</a:t>
+              <a:t>The longest lab. Check before class that the starter imports into your trial account and that the trial shows Gateway credits (or the class credential works).
+For a non-technical group, or where IT blocks n8n or the mailbox connection, build 10.1 to 10.6 on screen while they follow, then have them predict each route before it runs in 10.7. The locked-down page in the product cards gives the options.</a:t>
             </a:r>
             <a:endParaRPr lang="en-US" dirty="0"/>
           </a:p>
@@ -5037,7 +5038,7 @@
             <a:r>
               <a:rPr lang="en-US" dirty="0"/>
               <a:t>Each brief has its own sample data, with the tricky cases built in. Don't reveal them: teams find them in 13.3.
-Two teams can pick the same brief. Their designs will differ.</a:t>
+Two teams can pick the same brief. Their designs will differ. Steer HR participants to Brief D.</a:t>
             </a:r>
             <a:endParaRPr lang="en-US" dirty="0"/>
           </a:p>
@@ -35083,7 +35084,7 @@
                   <a:schemeClr val="tx1"/>
                 </a:solidFill>
               </a:rPr>
-              <a:t>Pick one of three briefs</a:t>
+              <a:t>Pick one of four briefs</a:t>
             </a:r>
             <a:endParaRPr lang="en-US" sz="3200" dirty="0"/>
           </a:p>
@@ -35122,7 +35123,7 @@
         <p:spPr>
           <a:xfrm>
             <a:off x="548640" y="2743200"/>
-            <a:ext cx="3444240" cy="777240"/>
+            <a:ext cx="2491740" cy="777240"/>
           </a:xfrm>
           <a:prstGeom prst="rect">
             <a:avLst/>
@@ -35161,7 +35162,7 @@
         <p:spPr>
           <a:xfrm>
             <a:off x="548640" y="3566160"/>
-            <a:ext cx="3352800" cy="1828800"/>
+            <a:ext cx="2400300" cy="1828800"/>
           </a:xfrm>
           <a:prstGeom prst="rect">
             <a:avLst/>
@@ -35204,7 +35205,7 @@
         </p:blipFill>
         <p:spPr>
           <a:xfrm>
-            <a:off x="4358640" y="2011680"/>
+            <a:off x="3406140" y="2011680"/>
             <a:ext cx="502920" cy="502920"/>
           </a:xfrm>
           <a:prstGeom prst="rect">
@@ -35220,8 +35221,8 @@
         </p:nvSpPr>
         <p:spPr>
           <a:xfrm>
-            <a:off x="4358640" y="2743200"/>
-            <a:ext cx="3444240" cy="777240"/>
+            <a:off x="3406140" y="2743200"/>
+            <a:ext cx="2491740" cy="777240"/>
           </a:xfrm>
           <a:prstGeom prst="rect">
             <a:avLst/>
@@ -35259,8 +35260,8 @@
         </p:nvSpPr>
         <p:spPr>
           <a:xfrm>
-            <a:off x="4358640" y="3566160"/>
-            <a:ext cx="3352800" cy="1828800"/>
+            <a:off x="3406140" y="3566160"/>
+            <a:ext cx="2400300" cy="1828800"/>
           </a:xfrm>
           <a:prstGeom prst="rect">
             <a:avLst/>
@@ -35303,7 +35304,7 @@
         </p:blipFill>
         <p:spPr>
           <a:xfrm>
-            <a:off x="8168640" y="2011680"/>
+            <a:off x="6263640" y="2011680"/>
             <a:ext cx="502920" cy="502920"/>
           </a:xfrm>
           <a:prstGeom prst="rect">
@@ -35319,8 +35320,8 @@
         </p:nvSpPr>
         <p:spPr>
           <a:xfrm>
-            <a:off x="8168640" y="2743200"/>
-            <a:ext cx="3444240" cy="777240"/>
+            <a:off x="6263640" y="2743200"/>
+            <a:ext cx="2491740" cy="777240"/>
           </a:xfrm>
           <a:prstGeom prst="rect">
             <a:avLst/>
@@ -35358,8 +35359,8 @@
         </p:nvSpPr>
         <p:spPr>
           <a:xfrm>
-            <a:off x="8168640" y="3566160"/>
-            <a:ext cx="3352800" cy="1828800"/>
+            <a:off x="6263640" y="3566160"/>
+            <a:ext cx="2400300" cy="1828800"/>
           </a:xfrm>
           <a:prstGeom prst="rect">
             <a:avLst/>
@@ -35381,6 +35382,105 @@
                 </a:solidFill>
               </a:rPr>
               <a:t>Procurement reports spend against budget to the Finance Director</a:t>
+            </a:r>
+            <a:endParaRPr lang="en-US" sz="1600" dirty="0"/>
+          </a:p>
+        </p:txBody>
+      </p:sp>
+      <p:pic>
+        <p:nvPicPr>
+          <p:cNvPr id="14" name="Image 3" descr="preencoded.png">    </p:cNvPr>
+          <p:cNvPicPr>
+            <a:picLocks noChangeAspect="1"/>
+          </p:cNvPicPr>
+          <p:nvPr/>
+        </p:nvPicPr>
+        <p:blipFill>
+          <a:blip r:embed="rId4"/>
+          <a:stretch>
+            <a:fillRect/>
+          </a:stretch>
+        </p:blipFill>
+        <p:spPr>
+          <a:xfrm>
+            <a:off x="9121140" y="2011680"/>
+            <a:ext cx="502920" cy="502920"/>
+          </a:xfrm>
+          <a:prstGeom prst="rect">
+            <a:avLst/>
+          </a:prstGeom>
+        </p:spPr>
+      </p:pic>
+      <p:sp>
+        <p:nvSpPr>
+          <p:cNvPr id="15" name="Text 8"/>
+          <p:cNvSpPr txBox="1"/>
+          <p:nvPr/>
+        </p:nvSpPr>
+        <p:spPr>
+          <a:xfrm>
+            <a:off x="9121140" y="2743200"/>
+            <a:ext cx="2491740" cy="777240"/>
+          </a:xfrm>
+          <a:prstGeom prst="rect">
+            <a:avLst/>
+          </a:prstGeom>
+          <a:noFill/>
+          <a:ln/>
+        </p:spPr>
+        <p:txBody>
+          <a:bodyPr wrap="square" lIns="0" tIns="0" rIns="0" bIns="0" rtlCol="0" anchor="t"/>
+          <a:lstStyle/>
+          <a:p>
+            <a:pPr indent="0" marL="0">
+              <a:buNone/>
+            </a:pPr>
+            <a:r>
+              <a:rPr lang="en-US" sz="1900" dirty="0">
+                <a:solidFill>
+                  <a:schemeClr val="tx1"/>
+                </a:solidFill>
+                <a:latin typeface="Segoe UI Semibold" pitchFamily="34" charset="0"/>
+                <a:ea typeface="Segoe UI Semibold" pitchFamily="34" charset="-122"/>
+                <a:cs typeface="Segoe UI Semibold" pitchFamily="34" charset="-120"/>
+              </a:rPr>
+              <a:t>D: Staff leave queries</a:t>
+            </a:r>
+            <a:endParaRPr lang="en-US" sz="1900" dirty="0"/>
+          </a:p>
+        </p:txBody>
+      </p:sp>
+      <p:sp>
+        <p:nvSpPr>
+          <p:cNvPr id="16" name="Text 9"/>
+          <p:cNvSpPr txBox="1"/>
+          <p:nvPr/>
+        </p:nvSpPr>
+        <p:spPr>
+          <a:xfrm>
+            <a:off x="9121140" y="3566160"/>
+            <a:ext cx="2400300" cy="1828800"/>
+          </a:xfrm>
+          <a:prstGeom prst="rect">
+            <a:avLst/>
+          </a:prstGeom>
+          <a:noFill/>
+          <a:ln/>
+        </p:spPr>
+        <p:txBody>
+          <a:bodyPr wrap="square" lIns="0" tIns="0" rIns="0" bIns="0" rtlCol="0" anchor="t"/>
+          <a:lstStyle/>
+          <a:p>
+            <a:pPr indent="0" marL="0">
+              <a:buNone/>
+            </a:pPr>
+            <a:r>
+              <a:rPr lang="en-US" sz="1600" dirty="0">
+                <a:solidFill>
+                  <a:schemeClr val="tx1"/>
+                </a:solidFill>
+              </a:rPr>
+              <a:t>HR answers staff emails about leave, with personal data to protect</a:t>
             </a:r>
             <a:endParaRPr lang="en-US" sz="1600" dirty="0"/>
           </a:p>

</xml_diff>

<commit_message>
Fix the issues from Codex's student walkthrough audit
Module 10 opens the form with Execute workflow so the whole workflow
runs; the vendor check compares whole names; 9.4 asks for the passages
used, not a retrieval log; 12.2's rules and box agree; the DPO duty is
scoped to organisations that meet the criteria; plus smaller wording
fixes in 01, 02, 07 and 10.1. Deck and book rebuilt.

Co-Authored-By: Claude Opus 5.5 <noreply@anthropic.com>
Claude-Session: https://claude.ai/code/session_01F3jTzTeVDh4aZxEw8vbSHh
</commit_message>
<xml_diff>
--- a/AI-for-Workplace-Advanced-Deck.pptx
+++ b/AI-for-Workplace-Advanced-Deck.pptx
@@ -4682,7 +4682,7 @@
           <a:p>
             <a:r>
               <a:rPr lang="en-US" dirty="0"/>
-              <a:t>PDPA amendments: in force from 1 June 2025 (Data Protection Officer, breach notification, data portability).
+              <a:t>PDPA amendments: in force from 1 June 2025 (a Data Protection Officer where the Commissioner's criteria apply, breach notification, data portability).
 AIGE: MOSTI, September 2024, voluntary.
 AI Governance Bill: public consultation by the National AI Office in July 2026, a risk-based draft. Not law as of October 2026: check before class.</a:t>
             </a:r>
@@ -33022,7 +33022,7 @@
                   <a:schemeClr val="tx1"/>
                 </a:solidFill>
               </a:rPr>
-              <a:t>Personal data in AI tools. A DPO, breach notification and data portability from 1 June 2025</a:t>
+              <a:t>Personal data in AI tools. A DPO where the criteria apply, breach notification and data portability from 1 June 2025</a:t>
             </a:r>
             <a:endParaRPr lang="en-US" sz="1600" dirty="0"/>
           </a:p>

</xml_diff>

<commit_message>
Deck: add the Module 02 Key point to the speaker notes
Co-Authored-By: Claude Opus 5.5 <noreply@anthropic.com>
Claude-Session: https://claude.ai/code/session_01F3jTzTeVDh4aZxEw8vbSHh
</commit_message>
<xml_diff>
--- a/AI-for-Workplace-Advanced-Deck.pptx
+++ b/AI-for-Workplace-Advanced-Deck.pptx
@@ -1045,7 +1045,7 @@
           <a:p>
             <a:r>
               <a:rPr lang="en-US" dirty="0"/>
-              <a:t>Chaining: check each step before the next depends on it. One big prompt makes mistakes hard to find.
+              <a:t>Chaining: check each step before the next depends on it. One big prompt makes mistakes hard to find. That doesn't make long prompts bad: once a chain works, its steps become standing instructions (Module 03).
 JSON matters on Day 2: the n8n workflow needs the AI's answer as fields, not a paragraph.</a:t>
             </a:r>
             <a:endParaRPr lang="en-US" dirty="0"/>
@@ -1135,7 +1135,8 @@
             <a:r>
               <a:rPr lang="en-US" dirty="0"/>
               <a:t>About 40 minutes. Uses the RFQ from Module 01's ZIP.
-There's no single right answer here: outputs vary. Check that rows can be quoted from the RFQ, and that steps 1 to 3 ran in the same chat.</a:t>
+There's no single right answer here: outputs vary. Check that rows can be quoted from the RFQ, and that steps 1 to 3 ran in the same chat.
+Debrief 2.4 with the Key point: chain a new job, or one where a mistake matters. One prompt is fine for a quick task, and a long prompt with numbered steps, a source boundary and a set format beats the 2.4 one-liner. Once each step works reliably, fold the steps into standing instructions: that's the Quotation Checker in Module 03.</a:t>
             </a:r>
             <a:endParaRPr lang="en-US" dirty="0"/>
           </a:p>

</xml_diff>